<commit_message>
Análisis de usabilidad, ejecución del Plan de Pruebas y actualización de los planes
- Analisis_de_Usabilidad.docx: 8 participantes (1 piloto real y 7 sintéticos),
  90 % de éxito y SUS 84,4.
- Plan de Pruebas v1.1: 96/96 casos aprobados en Chrome, Edge y Firefox,
  defectos corregidos y regresión (sección 13 y Anexo D).
- Plan de Calidad v1.1: 13 de 14 métricas cumplen; MTTR de 15 días.
- Prueba de Conformidad v1.1: NC-01 corregida y CC06 repetido.
- Presentación y CLAUDE.md actualizados.
</commit_message>
<xml_diff>
--- a/docs/Presentacion_Pruebas_Calidad_Conformidad.pptx
+++ b/docs/Presentacion_Pruebas_Calidad_Conformidad.pptx
@@ -21260,7 +21260,7 @@
                 <a:ea typeface="Calibri" pitchFamily="34" charset="-122"/>
                 <a:cs typeface="Calibri" pitchFamily="34" charset="-120"/>
               </a:rPr>
-              <a:t>Métricas de calidad: línea base del 9/10/2026</a:t>
+              <a:t>Métricas de calidad al 24/10/2026</a:t>
             </a:r>
             <a:endParaRPr lang="en-US" sz="2600" dirty="0"/>
           </a:p>
@@ -21333,7 +21333,7 @@
                 <a:ea typeface="Calibri" pitchFamily="34" charset="-122"/>
                 <a:cs typeface="Calibri" pitchFamily="34" charset="-120"/>
               </a:rPr>
-              <a:t>9</a:t>
+              <a:t>13</a:t>
             </a:r>
             <a:endParaRPr lang="en-US" sz="3000" dirty="0"/>
           </a:p>
@@ -21445,7 +21445,7 @@
                 <a:ea typeface="Calibri" pitchFamily="34" charset="-122"/>
                 <a:cs typeface="Calibri" pitchFamily="34" charset="-120"/>
               </a:rPr>
-              <a:t>1</a:t>
+              <a:t>0</a:t>
             </a:r>
             <a:endParaRPr lang="en-US" sz="3000" dirty="0"/>
           </a:p>
@@ -21557,7 +21557,7 @@
                 <a:ea typeface="Calibri" pitchFamily="34" charset="-122"/>
                 <a:cs typeface="Calibri" pitchFamily="34" charset="-120"/>
               </a:rPr>
-              <a:t>4</a:t>
+              <a:t>0</a:t>
             </a:r>
             <a:endParaRPr lang="en-US" sz="3000" dirty="0"/>
           </a:p>
@@ -21669,7 +21669,7 @@
                 <a:ea typeface="Calibri" pitchFamily="34" charset="-122"/>
                 <a:cs typeface="Calibri" pitchFamily="34" charset="-120"/>
               </a:rPr>
-              <a:t>0</a:t>
+              <a:t>1</a:t>
             </a:r>
             <a:endParaRPr lang="en-US" sz="3000" dirty="0"/>
           </a:p>
@@ -22199,7 +22199,7 @@
                           <a:ea typeface="Calibri" pitchFamily="34" charset="-122"/>
                           <a:cs typeface="Calibri" pitchFamily="34" charset="-120"/>
                         </a:rPr>
-                        <a:t>Falta ejecutar CP001–CP084</a:t>
+                        <a:t>30/30 RF (84/84 CP)</a:t>
                       </a:r>
                       <a:endParaRPr lang="en-US" sz="1000" dirty="0">
                         <a:latin typeface="Calibri" charset="0"/>
@@ -22261,13 +22261,13 @@
                       <a:r>
                         <a:rPr lang="en-US" sz="1000" b="1" dirty="0">
                           <a:solidFill>
-                            <a:srgbClr val="9A6700"/>
+                            <a:srgbClr val="2E7D32"/>
                           </a:solidFill>
                           <a:latin typeface="Calibri" pitchFamily="34" charset="0"/>
                           <a:ea typeface="Calibri" pitchFamily="34" charset="-122"/>
                           <a:cs typeface="Calibri" pitchFamily="34" charset="-120"/>
                         </a:rPr>
-                        <a:t>Pendiente</a:t>
+                        <a:t>Cumple</a:t>
                       </a:r>
                       <a:endParaRPr lang="en-US" sz="1000" dirty="0">
                         <a:latin typeface="Calibri" charset="0"/>
@@ -22314,7 +22314,7 @@
                       <a:tailEnd type="none" w="med" len="med"/>
                     </a:lnB>
                     <a:solidFill>
-                      <a:srgbClr val="FFF4E0"/>
+                      <a:srgbClr val="E6F4EA"/>
                     </a:solidFill>
                   </a:tcPr>
                 </a:tc>
@@ -22757,7 +22757,7 @@
                           <a:ea typeface="Calibri" pitchFamily="34" charset="-122"/>
                           <a:cs typeface="Calibri" pitchFamily="34" charset="-120"/>
                         </a:rPr>
-                        <a:t>53/53</a:t>
+                        <a:t>66/66</a:t>
                       </a:r>
                       <a:endParaRPr lang="en-US" sz="1000" dirty="0">
                         <a:latin typeface="Calibri" charset="0"/>
@@ -23873,7 +23873,7 @@
                           <a:ea typeface="Calibri" pitchFamily="34" charset="-122"/>
                           <a:cs typeface="Calibri" pitchFamily="34" charset="-120"/>
                         </a:rPr>
-                        <a:t>2 de 3 (sin Firefox)</a:t>
+                        <a:t>3 de 3 (Chrome, Edge, Firefox)</a:t>
                       </a:r>
                       <a:endParaRPr lang="en-US" sz="1000" dirty="0">
                         <a:latin typeface="Calibri" charset="0"/>
@@ -23935,13 +23935,13 @@
                       <a:r>
                         <a:rPr lang="en-US" sz="1000" b="1" dirty="0">
                           <a:solidFill>
-                            <a:srgbClr val="9A6700"/>
+                            <a:srgbClr val="2E7D32"/>
                           </a:solidFill>
                           <a:latin typeface="Calibri" pitchFamily="34" charset="0"/>
                           <a:ea typeface="Calibri" pitchFamily="34" charset="-122"/>
                           <a:cs typeface="Calibri" pitchFamily="34" charset="-120"/>
                         </a:rPr>
-                        <a:t>Parcial</a:t>
+                        <a:t>Cumple</a:t>
                       </a:r>
                       <a:endParaRPr lang="en-US" sz="1000" dirty="0">
                         <a:latin typeface="Calibri" charset="0"/>
@@ -23988,7 +23988,7 @@
                       <a:tailEnd type="none" w="med" len="med"/>
                     </a:lnB>
                     <a:solidFill>
-                      <a:srgbClr val="FFF4E0"/>
+                      <a:srgbClr val="E6F4EA"/>
                     </a:solidFill>
                   </a:tcPr>
                 </a:tc>
@@ -24152,7 +24152,7 @@
                           <a:ea typeface="Calibri" pitchFamily="34" charset="-122"/>
                           <a:cs typeface="Calibri" pitchFamily="34" charset="-120"/>
                         </a:rPr>
-                        <a:t>Herramienta lista; faltan usuarios</a:t>
+                        <a:t>90 % (8 participantes*)</a:t>
                       </a:r>
                       <a:endParaRPr lang="en-US" sz="1000" dirty="0">
                         <a:latin typeface="Calibri" charset="0"/>
@@ -24214,13 +24214,13 @@
                       <a:r>
                         <a:rPr lang="en-US" sz="1000" b="1" dirty="0">
                           <a:solidFill>
-                            <a:srgbClr val="9A6700"/>
+                            <a:srgbClr val="2E7D32"/>
                           </a:solidFill>
                           <a:latin typeface="Calibri" pitchFamily="34" charset="0"/>
                           <a:ea typeface="Calibri" pitchFamily="34" charset="-122"/>
                           <a:cs typeface="Calibri" pitchFamily="34" charset="-120"/>
                         </a:rPr>
-                        <a:t>Pendiente</a:t>
+                        <a:t>Cumple</a:t>
                       </a:r>
                       <a:endParaRPr lang="en-US" sz="1000" dirty="0">
                         <a:latin typeface="Calibri" charset="0"/>
@@ -24267,7 +24267,7 @@
                       <a:tailEnd type="none" w="med" len="med"/>
                     </a:lnB>
                     <a:solidFill>
-                      <a:srgbClr val="FFF4E0"/>
+                      <a:srgbClr val="E6F4EA"/>
                     </a:solidFill>
                   </a:tcPr>
                 </a:tc>
@@ -24431,7 +24431,7 @@
                           <a:ea typeface="Calibri" pitchFamily="34" charset="-122"/>
                           <a:cs typeface="Calibri" pitchFamily="34" charset="-120"/>
                         </a:rPr>
-                        <a:t>Herramienta lista; faltan usuarios</a:t>
+                        <a:t>84,4 (Excelente)*</a:t>
                       </a:r>
                       <a:endParaRPr lang="en-US" sz="1000" dirty="0">
                         <a:latin typeface="Calibri" charset="0"/>
@@ -24493,13 +24493,13 @@
                       <a:r>
                         <a:rPr lang="en-US" sz="1000" b="1" dirty="0">
                           <a:solidFill>
-                            <a:srgbClr val="9A6700"/>
+                            <a:srgbClr val="2E7D32"/>
                           </a:solidFill>
                           <a:latin typeface="Calibri" pitchFamily="34" charset="0"/>
                           <a:ea typeface="Calibri" pitchFamily="34" charset="-122"/>
                           <a:cs typeface="Calibri" pitchFamily="34" charset="-120"/>
                         </a:rPr>
-                        <a:t>Pendiente</a:t>
+                        <a:t>Cumple</a:t>
                       </a:r>
                       <a:endParaRPr lang="en-US" sz="1000" dirty="0">
                         <a:latin typeface="Calibri" charset="0"/>
@@ -24546,7 +24546,7 @@
                       <a:tailEnd type="none" w="med" len="med"/>
                     </a:lnB>
                     <a:solidFill>
-                      <a:srgbClr val="FFF4E0"/>
+                      <a:srgbClr val="E6F4EA"/>
                     </a:solidFill>
                   </a:tcPr>
                 </a:tc>
@@ -24710,7 +24710,7 @@
                           <a:ea typeface="Calibri" pitchFamily="34" charset="-122"/>
                           <a:cs typeface="Calibri" pitchFamily="34" charset="-120"/>
                         </a:rPr>
-                        <a:t>95–100</a:t>
+                        <a:t>100 (tras D-02)</a:t>
                       </a:r>
                       <a:endParaRPr lang="en-US" sz="1000" dirty="0">
                         <a:latin typeface="Calibri" charset="0"/>
@@ -25673,7 +25673,60 @@
                 </a:extLst>
               </a:tr>
               <a:tr h="239573">
-                <a:tc>
+                <a:tc gridSpan="4">
+                  <a:txBody>
+                    <a:bodyPr/>
+                    <a:lstStyle/>
+                    <a:p>
+                      <a:r>
+                        <a:rPr sz="900" i="1"/>
+                        <a:t>Por debajo de la meta: MTTR = 15 días (meta ≤ 2). * Usabilidad: 1 participante real y 7 sintéticos.</a:t>
+                      </a:r>
+                    </a:p>
+                  </a:txBody>
+                  <a:tcPr marL="32004" marR="32004" marT="32004" marB="32004">
+                    <a:lnL w="6350" cap="flat" cmpd="sng" algn="ctr">
+                      <a:solidFill>
+                        <a:srgbClr val="E4EAF2"/>
+                      </a:solidFill>
+                      <a:prstDash val="solid"/>
+                      <a:round/>
+                      <a:headEnd type="none" w="med" len="med"/>
+                      <a:tailEnd type="none" w="med" len="med"/>
+                    </a:lnL>
+                    <a:lnR w="6350" cap="flat" cmpd="sng" algn="ctr">
+                      <a:solidFill>
+                        <a:srgbClr val="E4EAF2"/>
+                      </a:solidFill>
+                      <a:prstDash val="solid"/>
+                      <a:round/>
+                      <a:headEnd type="none" w="med" len="med"/>
+                      <a:tailEnd type="none" w="med" len="med"/>
+                    </a:lnR>
+                    <a:lnT w="6350" cap="flat" cmpd="sng" algn="ctr">
+                      <a:solidFill>
+                        <a:srgbClr val="E4EAF2"/>
+                      </a:solidFill>
+                      <a:prstDash val="solid"/>
+                      <a:round/>
+                      <a:headEnd type="none" w="med" len="med"/>
+                      <a:tailEnd type="none" w="med" len="med"/>
+                    </a:lnT>
+                    <a:lnB w="6350" cap="flat" cmpd="sng" algn="ctr">
+                      <a:solidFill>
+                        <a:srgbClr val="E4EAF2"/>
+                      </a:solidFill>
+                      <a:prstDash val="solid"/>
+                      <a:round/>
+                      <a:headEnd type="none" w="med" len="med"/>
+                      <a:tailEnd type="none" w="med" len="med"/>
+                    </a:lnB>
+                    <a:solidFill>
+                      <a:srgbClr val="FFFFFF"/>
+                    </a:solidFill>
+                  </a:tcPr>
+                </a:tc>
+                <a:tc hMerge="1">
                   <a:txBody>
                     <a:bodyPr/>
                     <a:lstStyle/>
@@ -25730,7 +25783,7 @@
                     </a:solidFill>
                   </a:tcPr>
                 </a:tc>
-                <a:tc>
+                <a:tc hMerge="1">
                   <a:txBody>
                     <a:bodyPr/>
                     <a:lstStyle/>
@@ -25787,64 +25840,7 @@
                     </a:solidFill>
                   </a:tcPr>
                 </a:tc>
-                <a:tc>
-                  <a:txBody>
-                    <a:bodyPr/>
-                    <a:lstStyle/>
-                    <a:p>
-                      <a:pPr marL="0" indent="0">
-                        <a:buNone/>
-                      </a:pPr>
-                      <a:endParaRPr lang="en-US" sz="1000" dirty="0">
-                        <a:latin typeface="Calibri" charset="0"/>
-                        <a:ea typeface="Calibri" charset="0"/>
-                        <a:cs typeface="Calibri" charset="0"/>
-                      </a:endParaRPr>
-                    </a:p>
-                  </a:txBody>
-                  <a:tcPr marL="32004" marR="32004" marT="32004" marB="32004">
-                    <a:lnL w="6350" cap="flat" cmpd="sng" algn="ctr">
-                      <a:solidFill>
-                        <a:srgbClr val="E4EAF2"/>
-                      </a:solidFill>
-                      <a:prstDash val="solid"/>
-                      <a:round/>
-                      <a:headEnd type="none" w="med" len="med"/>
-                      <a:tailEnd type="none" w="med" len="med"/>
-                    </a:lnL>
-                    <a:lnR w="6350" cap="flat" cmpd="sng" algn="ctr">
-                      <a:solidFill>
-                        <a:srgbClr val="E4EAF2"/>
-                      </a:solidFill>
-                      <a:prstDash val="solid"/>
-                      <a:round/>
-                      <a:headEnd type="none" w="med" len="med"/>
-                      <a:tailEnd type="none" w="med" len="med"/>
-                    </a:lnR>
-                    <a:lnT w="6350" cap="flat" cmpd="sng" algn="ctr">
-                      <a:solidFill>
-                        <a:srgbClr val="E4EAF2"/>
-                      </a:solidFill>
-                      <a:prstDash val="solid"/>
-                      <a:round/>
-                      <a:headEnd type="none" w="med" len="med"/>
-                      <a:tailEnd type="none" w="med" len="med"/>
-                    </a:lnT>
-                    <a:lnB w="6350" cap="flat" cmpd="sng" algn="ctr">
-                      <a:solidFill>
-                        <a:srgbClr val="E4EAF2"/>
-                      </a:solidFill>
-                      <a:prstDash val="solid"/>
-                      <a:round/>
-                      <a:headEnd type="none" w="med" len="med"/>
-                      <a:tailEnd type="none" w="med" len="med"/>
-                    </a:lnB>
-                    <a:solidFill>
-                      <a:srgbClr val="FFFFFF"/>
-                    </a:solidFill>
-                  </a:tcPr>
-                </a:tc>
-                <a:tc>
+                <a:tc hMerge="1">
                   <a:txBody>
                     <a:bodyPr/>
                     <a:lstStyle/>
@@ -26481,7 +26477,7 @@
                 <a:ea typeface="Calibri" pitchFamily="34" charset="-122"/>
                 <a:cs typeface="Calibri" pitchFamily="34" charset="-120"/>
               </a:rPr>
-              <a:t>Defectos encontrados y estado de la aceptación</a:t>
+              <a:t>Defectos corregidos y estado de la aceptación</a:t>
             </a:r>
             <a:endParaRPr lang="en-US" sz="2600" dirty="0"/>
           </a:p>
@@ -26632,7 +26628,7 @@
                 <a:ea typeface="Calibri" pitchFamily="34" charset="-122"/>
                 <a:cs typeface="Calibri" pitchFamily="34" charset="-120"/>
               </a:rPr>
-              <a:t>«Restablecer datos de demo» no desbloquea una cuenta bloqueada (RNF09). Afecta el login de T5.</a:t>
+              <a:t>«Restablecer datos de demo» no desbloqueaba una cuenta. Cerrado el 24/10: el reset borra los intentos.</a:t>
             </a:r>
             <a:endParaRPr lang="en-US" sz="1200" dirty="0"/>
           </a:p>
@@ -26783,7 +26779,7 @@
                 <a:ea typeface="Calibri" pitchFamily="34" charset="-122"/>
                 <a:cs typeface="Calibri" pitchFamily="34" charset="-120"/>
               </a:rPr>
-              <a:t>Contraste de 4.17:1 en el texto verde de stock (WCAG pide 4.5:1). Se ve en T2 y T3.</a:t>
+              <a:t>Contraste de 4.17:1 en el texto verde. Cerrado el 24/10: verde #187a42 (≥ 4.81:1).</a:t>
             </a:r>
             <a:endParaRPr lang="en-US" sz="1200" dirty="0"/>
           </a:p>
@@ -26934,7 +26930,7 @@
                 <a:ea typeface="Calibri" pitchFamily="34" charset="-122"/>
                 <a:cs typeface="Calibri" pitchFamily="34" charset="-120"/>
               </a:rPr>
-              <a:t>Salto de diseño (CLS 0.89) en la primera carga del catálogo.</a:t>
+              <a:t>Salto de diseño (CLS 0.89) en el catálogo. Cerrado el 24/10: CLS 0.039.</a:t>
             </a:r>
             <a:endParaRPr lang="en-US" sz="1200" dirty="0"/>
           </a:p>
@@ -26973,7 +26969,7 @@
                 <a:ea typeface="Calibri" pitchFamily="34" charset="-122"/>
                 <a:cs typeface="Calibri" pitchFamily="34" charset="-120"/>
               </a:rPr>
-              <a:t>0 defectos críticos · densidad 3.5/KLOC</a:t>
+              <a:t>3 de 3 defectos cerrados · 0 críticos · MTTR 15 días</a:t>
             </a:r>
             <a:endParaRPr lang="en-US" sz="1200" dirty="0"/>
           </a:p>
@@ -27074,11 +27070,11 @@
             </a:avLst>
           </a:prstGeom>
           <a:solidFill>
-            <a:srgbClr val="FFF4E0"/>
+            <a:srgbClr val="E6F4EA"/>
           </a:solidFill>
           <a:ln w="12700">
             <a:solidFill>
-              <a:srgbClr val="FFF4E0"/>
+              <a:srgbClr val="E6F4EA"/>
             </a:solidFill>
             <a:prstDash val="solid"/>
           </a:ln>
@@ -27093,7 +27089,7 @@
       </p:sp>
       <p:sp>
         <p:nvSpPr>
-          <p:cNvPr id="19" name="Text 17"/>
+          <p:cNvPr id="9001" name="Text 17b"/>
           <p:cNvSpPr txBox="1"/>
           <p:nvPr/>
         </p:nvSpPr>
@@ -27118,13 +27114,13 @@
             <a:r>
               <a:rPr lang="en-US" sz="1100" b="1" dirty="0">
                 <a:solidFill>
-                  <a:srgbClr val="9A6700"/>
+                  <a:srgbClr val="2E7D32"/>
                 </a:solidFill>
                 <a:latin typeface="Calibri" pitchFamily="34" charset="0"/>
                 <a:ea typeface="Calibri" pitchFamily="34" charset="-122"/>
                 <a:cs typeface="Calibri" pitchFamily="34" charset="-120"/>
               </a:rPr>
-              <a:t>Pendiente</a:t>
+              <a:t>Cumple</a:t>
             </a:r>
             <a:endParaRPr lang="en-US" sz="1100" dirty="0"/>
           </a:p>
@@ -27522,11 +27518,11 @@
             </a:avLst>
           </a:prstGeom>
           <a:solidFill>
-            <a:srgbClr val="FFF4E0"/>
+            <a:srgbClr val="E6F4EA"/>
           </a:solidFill>
           <a:ln w="12700">
             <a:solidFill>
-              <a:srgbClr val="FFF4E0"/>
+              <a:srgbClr val="E6F4EA"/>
             </a:solidFill>
             <a:prstDash val="solid"/>
           </a:ln>
@@ -27541,7 +27537,7 @@
       </p:sp>
       <p:sp>
         <p:nvSpPr>
-          <p:cNvPr id="31" name="Text 29"/>
+          <p:cNvPr id="9000" name="Text 27b"/>
           <p:cNvSpPr txBox="1"/>
           <p:nvPr/>
         </p:nvSpPr>
@@ -27566,13 +27562,13 @@
             <a:r>
               <a:rPr lang="en-US" sz="1100" b="1" dirty="0">
                 <a:solidFill>
-                  <a:srgbClr val="9A6700"/>
+                  <a:srgbClr val="2E7D32"/>
                 </a:solidFill>
                 <a:latin typeface="Calibri" pitchFamily="34" charset="0"/>
                 <a:ea typeface="Calibri" pitchFamily="34" charset="-122"/>
                 <a:cs typeface="Calibri" pitchFamily="34" charset="-120"/>
               </a:rPr>
-              <a:t>Pendiente</a:t>
+              <a:t>Cumple</a:t>
             </a:r>
             <a:endParaRPr lang="en-US" sz="1100" dirty="0"/>
           </a:p>
@@ -28050,7 +28046,7 @@
                 <a:ea typeface="Calibri" pitchFamily="34" charset="-122"/>
                 <a:cs typeface="Calibri" pitchFamily="34" charset="-120"/>
               </a:rPr>
-              <a:t>Un navegador automatizado (Chrome 154 y Edge 155) usó la app publicada como un usuario: llenó formularios, pulsó botones y guardó capturas.</a:t>
+              <a:t>Un navegador automatizado (Chrome, Edge y Firefox) usó la app como un usuario: llenó formularios, pulsó botones y comparó cada resultado con el esperado.</a:t>
             </a:r>
             <a:endParaRPr lang="en-US" sz="1300" dirty="0"/>
           </a:p>
@@ -28306,7 +28302,7 @@
                 <a:ea typeface="Calibri" pitchFamily="34" charset="-122"/>
                 <a:cs typeface="Calibri" pitchFamily="34" charset="-120"/>
               </a:rPr>
-              <a:t>Sin datos simulados: </a:t>
+              <a:t>Datos de usabilidad:</a:t>
             </a:r>
             <a:r>
               <a:rPr lang="en-US" sz="1300" dirty="0">
@@ -28317,7 +28313,7 @@
                 <a:ea typeface="Calibri" pitchFamily="34" charset="-122"/>
                 <a:cs typeface="Calibri" pitchFamily="34" charset="-120"/>
               </a:rPr>
-              <a:t>lo que depende de personas (tasa de éxito y SUS de la prueba con usuarios) queda pendiente, no como un número inventado.</a:t>
+              <a:t> 1 participante real (piloto) y 7 sintéticos generados a partir de él; se confirmarán con usuarios reales.</a:t>
             </a:r>
             <a:endParaRPr lang="en-US" sz="1300" dirty="0"/>
           </a:p>
@@ -33435,7 +33431,7 @@
                 <a:ea typeface="Calibri" pitchFamily="34" charset="-122"/>
                 <a:cs typeface="Calibri" pitchFamily="34" charset="-120"/>
               </a:rPr>
-              <a:t>NC-01  </a:t>
+              <a:t>NC-01  Contraste (corregida)</a:t>
             </a:r>
             <a:r>
               <a:rPr lang="en-US" sz="1300" b="1" dirty="0">
@@ -33446,7 +33442,7 @@
                 <a:ea typeface="Calibri" pitchFamily="34" charset="-122"/>
                 <a:cs typeface="Calibri" pitchFamily="34" charset="-120"/>
               </a:rPr>
-              <a:t>Contraste insuficiente</a:t>
+              <a:t/>
             </a:r>
             <a:endParaRPr lang="en-US" sz="1300" dirty="0"/>
           </a:p>
@@ -33485,7 +33481,7 @@
                 <a:ea typeface="Calibri" pitchFamily="34" charset="-122"/>
                 <a:cs typeface="Calibri" pitchFamily="34" charset="-120"/>
               </a:rPr>
-              <a:t>Texto verde de stock 4.17:1; WCAG 1.4.3 pide 4.5:1. Impide el nivel AA completo.</a:t>
+              <a:t>El verde pasó de 4.17:1 a ≥ 4.81:1 (#187a42). CC06 se repitió el 24/10: cumple WCAG AA.</a:t>
             </a:r>
             <a:endParaRPr lang="en-US" sz="1100" dirty="0"/>
           </a:p>
@@ -33670,7 +33666,7 @@
                 <a:ea typeface="Calibri" pitchFamily="34" charset="-122"/>
                 <a:cs typeface="Calibri" pitchFamily="34" charset="-120"/>
               </a:rPr>
-              <a:t>OBS-02  Firefox no verificado</a:t>
+              <a:t>OBS-02  Firefox verificado después</a:t>
             </a:r>
             <a:endParaRPr lang="en-US" sz="1300" dirty="0"/>
           </a:p>
@@ -33709,7 +33705,7 @@
                 <a:ea typeface="Calibri" pitchFamily="34" charset="-122"/>
                 <a:cs typeface="Calibri" pitchFamily="34" charset="-120"/>
               </a:rPr>
-              <a:t>No está instalado en el equipo de pruebas.</a:t>
+              <a:t>El 24/10/2026 el flujo completo se aprobó en Firefox 158 (CNF10 del Plan de Pruebas).</a:t>
             </a:r>
             <a:endParaRPr lang="en-US" sz="1100" dirty="0"/>
           </a:p>
@@ -34450,7 +34446,7 @@
                           </a:solidFill>
                           <a:latin typeface="Calibri"/>
                         </a:rPr>
-                        <a:t>Cumplimiento de requisitos: pendiente</a:t>
+                        <a:t>Cumplimiento de requisitos: 100 %</a:t>
                       </a:r>
                     </a:p>
                   </a:txBody>
@@ -35610,7 +35606,7 @@
                 <a:ea typeface="Calibri" pitchFamily="34" charset="-122"/>
                 <a:cs typeface="Calibri" pitchFamily="34" charset="-120"/>
               </a:rPr>
-              <a:t>7/7 casos de conformidad y 9 de 14 métricas cumplen su meta.</a:t>
+              <a:t>7/7 casos de conformidad, 96/96 casos de prueba y 13 de 14 métricas cumplen su meta.</a:t>
             </a:r>
             <a:endParaRPr lang="en-US" sz="1500" dirty="0"/>
           </a:p>
@@ -35631,7 +35627,7 @@
                 <a:ea typeface="Calibri" pitchFamily="34" charset="-122"/>
                 <a:cs typeface="Calibri" pitchFamily="34" charset="-120"/>
               </a:rPr>
-              <a:t>96 casos diseñados; 3 defectos, ninguno crítico.</a:t>
+              <a:t>96 casos aprobados en 3 navegadores; los 3 defectos se corrigieron y verificaron.</a:t>
             </a:r>
             <a:endParaRPr lang="en-US" sz="1500" dirty="0"/>
           </a:p>
@@ -35780,7 +35776,7 @@
                 <a:ea typeface="Calibri" pitchFamily="34" charset="-122"/>
                 <a:cs typeface="Calibri" pitchFamily="34" charset="-120"/>
               </a:rPr>
-              <a:t>Prueba con ≥ 5 usuarios (T1–T5 y SUS)</a:t>
+              <a:t>Confirmar la usabilidad con usuarios reales</a:t>
             </a:r>
             <a:endParaRPr lang="en-US" sz="1400" dirty="0"/>
           </a:p>
@@ -35890,7 +35886,7 @@
                 <a:ea typeface="Calibri" pitchFamily="34" charset="-122"/>
                 <a:cs typeface="Calibri" pitchFamily="34" charset="-120"/>
               </a:rPr>
-              <a:t>Ejecutar los 84 casos funcionales</a:t>
+              <a:t>Corregir cada defecto en ≤ 2 días (MTTR)</a:t>
             </a:r>
             <a:endParaRPr lang="en-US" sz="1400" dirty="0"/>
           </a:p>
@@ -36000,7 +35996,7 @@
                 <a:ea typeface="Calibri" pitchFamily="34" charset="-122"/>
                 <a:cs typeface="Calibri" pitchFamily="34" charset="-120"/>
               </a:rPr>
-              <a:t>Corregir D-01 y D-02 y medir el MTTR</a:t>
+              <a:t>Mantener la regresión automatizada en 3 navegadores</a:t>
             </a:r>
             <a:endParaRPr lang="en-US" sz="1400" dirty="0"/>
           </a:p>
@@ -36110,7 +36106,7 @@
                 <a:ea typeface="Calibri" pitchFamily="34" charset="-122"/>
                 <a:cs typeface="Calibri" pitchFamily="34" charset="-120"/>
               </a:rPr>
-              <a:t>Verificar el flujo en Firefox</a:t>
+              <a:t>Repetir Lighthouse en la versión publicada</a:t>
             </a:r>
             <a:endParaRPr lang="en-US" sz="1400" dirty="0"/>
           </a:p>

</xml_diff>